<commit_message>
refactor: enhance RestTemplate with pooled HTTP client and improve error handling
</commit_message>
<xml_diff>
--- a/WebFlux-Reactive-vs-Blocking.pptx
+++ b/WebFlux-Reactive-vs-Blocking.pptx
@@ -43,7 +43,7 @@
     <p:sldId id="288" r:id="rId34"/>
   </p:sldIdLst>
   <p:sldSz cx="9144000" cy="5143500" type="screen16x9"/>
-  <p:notesSz cx="5143500" cy="9144000"/>
+  <p:notesSz cx="6792913" cy="9925050"/>
   <p:defaultTextStyle>
     <a:lvl1pPr marL="0" algn="l" defTabSz="914400" rtl="0" eaLnBrk="1" latinLnBrk="0" hangingPunct="1">
       <a:defRPr sz="1800" kern="1200">
@@ -310,7 +310,7 @@
         </p:nvSpPr>
         <p:spPr/>
         <p:txBody>
-          <a:bodyPr/>
+          <a:bodyPr lIns="106994" tIns="53497" rIns="106994" bIns="53497"/>
           <a:lstStyle/>
           <a:p>
             <a:endParaRPr lang="en-US" dirty="0"/>
@@ -329,7 +329,7 @@
         </p:nvSpPr>
         <p:spPr/>
         <p:txBody>
-          <a:bodyPr/>
+          <a:bodyPr lIns="106994" tIns="53497" rIns="106994" bIns="53497"/>
           <a:lstStyle/>
           <a:p>
             <a:fld id="{F7021451-1387-4CA6-816F-3879F97B5CBC}" type="slidenum">
@@ -394,7 +394,7 @@
         </p:nvSpPr>
         <p:spPr/>
         <p:txBody>
-          <a:bodyPr/>
+          <a:bodyPr lIns="106994" tIns="53497" rIns="106994" bIns="53497"/>
           <a:lstStyle/>
           <a:p>
             <a:endParaRPr lang="en-US" dirty="0"/>
@@ -413,7 +413,7 @@
         </p:nvSpPr>
         <p:spPr/>
         <p:txBody>
-          <a:bodyPr/>
+          <a:bodyPr lIns="106994" tIns="53497" rIns="106994" bIns="53497"/>
           <a:lstStyle/>
           <a:p>
             <a:fld id="{F7021451-1387-4CA6-816F-3879F97B5CBC}" type="slidenum">
@@ -478,7 +478,7 @@
         </p:nvSpPr>
         <p:spPr/>
         <p:txBody>
-          <a:bodyPr/>
+          <a:bodyPr lIns="106994" tIns="53497" rIns="106994" bIns="53497"/>
           <a:lstStyle/>
           <a:p>
             <a:endParaRPr lang="en-US" dirty="0"/>
@@ -497,7 +497,7 @@
         </p:nvSpPr>
         <p:spPr/>
         <p:txBody>
-          <a:bodyPr/>
+          <a:bodyPr lIns="106994" tIns="53497" rIns="106994" bIns="53497"/>
           <a:lstStyle/>
           <a:p>
             <a:fld id="{F7021451-1387-4CA6-816F-3879F97B5CBC}" type="slidenum">
@@ -562,7 +562,7 @@
         </p:nvSpPr>
         <p:spPr/>
         <p:txBody>
-          <a:bodyPr/>
+          <a:bodyPr lIns="106994" tIns="53497" rIns="106994" bIns="53497"/>
           <a:lstStyle/>
           <a:p>
             <a:endParaRPr lang="en-US" dirty="0"/>
@@ -581,7 +581,7 @@
         </p:nvSpPr>
         <p:spPr/>
         <p:txBody>
-          <a:bodyPr/>
+          <a:bodyPr lIns="106994" tIns="53497" rIns="106994" bIns="53497"/>
           <a:lstStyle/>
           <a:p>
             <a:fld id="{F7021451-1387-4CA6-816F-3879F97B5CBC}" type="slidenum">
@@ -646,7 +646,7 @@
         </p:nvSpPr>
         <p:spPr/>
         <p:txBody>
-          <a:bodyPr/>
+          <a:bodyPr lIns="106994" tIns="53497" rIns="106994" bIns="53497"/>
           <a:lstStyle/>
           <a:p>
             <a:endParaRPr lang="en-US" dirty="0"/>
@@ -665,7 +665,7 @@
         </p:nvSpPr>
         <p:spPr/>
         <p:txBody>
-          <a:bodyPr/>
+          <a:bodyPr lIns="106994" tIns="53497" rIns="106994" bIns="53497"/>
           <a:lstStyle/>
           <a:p>
             <a:fld id="{F7021451-1387-4CA6-816F-3879F97B5CBC}" type="slidenum">
@@ -730,7 +730,7 @@
         </p:nvSpPr>
         <p:spPr/>
         <p:txBody>
-          <a:bodyPr/>
+          <a:bodyPr lIns="106994" tIns="53497" rIns="106994" bIns="53497"/>
           <a:lstStyle/>
           <a:p>
             <a:endParaRPr lang="en-US" dirty="0"/>
@@ -749,7 +749,7 @@
         </p:nvSpPr>
         <p:spPr/>
         <p:txBody>
-          <a:bodyPr/>
+          <a:bodyPr lIns="106994" tIns="53497" rIns="106994" bIns="53497"/>
           <a:lstStyle/>
           <a:p>
             <a:fld id="{F7021451-1387-4CA6-816F-3879F97B5CBC}" type="slidenum">
@@ -814,7 +814,7 @@
         </p:nvSpPr>
         <p:spPr/>
         <p:txBody>
-          <a:bodyPr/>
+          <a:bodyPr lIns="106994" tIns="53497" rIns="106994" bIns="53497"/>
           <a:lstStyle/>
           <a:p>
             <a:endParaRPr lang="en-US" dirty="0"/>
@@ -833,7 +833,7 @@
         </p:nvSpPr>
         <p:spPr/>
         <p:txBody>
-          <a:bodyPr/>
+          <a:bodyPr lIns="106994" tIns="53497" rIns="106994" bIns="53497"/>
           <a:lstStyle/>
           <a:p>
             <a:fld id="{F7021451-1387-4CA6-816F-3879F97B5CBC}" type="slidenum">
@@ -898,7 +898,7 @@
         </p:nvSpPr>
         <p:spPr/>
         <p:txBody>
-          <a:bodyPr/>
+          <a:bodyPr lIns="106994" tIns="53497" rIns="106994" bIns="53497"/>
           <a:lstStyle/>
           <a:p>
             <a:endParaRPr lang="en-US" dirty="0"/>
@@ -917,7 +917,7 @@
         </p:nvSpPr>
         <p:spPr/>
         <p:txBody>
-          <a:bodyPr/>
+          <a:bodyPr lIns="106994" tIns="53497" rIns="106994" bIns="53497"/>
           <a:lstStyle/>
           <a:p>
             <a:fld id="{F7021451-1387-4CA6-816F-3879F97B5CBC}" type="slidenum">
@@ -982,7 +982,7 @@
         </p:nvSpPr>
         <p:spPr/>
         <p:txBody>
-          <a:bodyPr/>
+          <a:bodyPr lIns="106994" tIns="53497" rIns="106994" bIns="53497"/>
           <a:lstStyle/>
           <a:p>
             <a:endParaRPr lang="en-US" dirty="0"/>
@@ -1001,7 +1001,7 @@
         </p:nvSpPr>
         <p:spPr/>
         <p:txBody>
-          <a:bodyPr/>
+          <a:bodyPr lIns="106994" tIns="53497" rIns="106994" bIns="53497"/>
           <a:lstStyle/>
           <a:p>
             <a:fld id="{F7021451-1387-4CA6-816F-3879F97B5CBC}" type="slidenum">
@@ -1066,7 +1066,7 @@
         </p:nvSpPr>
         <p:spPr/>
         <p:txBody>
-          <a:bodyPr/>
+          <a:bodyPr lIns="106994" tIns="53497" rIns="106994" bIns="53497"/>
           <a:lstStyle/>
           <a:p>
             <a:endParaRPr lang="en-US" dirty="0"/>
@@ -1085,7 +1085,7 @@
         </p:nvSpPr>
         <p:spPr/>
         <p:txBody>
-          <a:bodyPr/>
+          <a:bodyPr lIns="106994" tIns="53497" rIns="106994" bIns="53497"/>
           <a:lstStyle/>
           <a:p>
             <a:fld id="{F7021451-1387-4CA6-816F-3879F97B5CBC}" type="slidenum">
@@ -1150,7 +1150,7 @@
         </p:nvSpPr>
         <p:spPr/>
         <p:txBody>
-          <a:bodyPr/>
+          <a:bodyPr lIns="106994" tIns="53497" rIns="106994" bIns="53497"/>
           <a:lstStyle/>
           <a:p>
             <a:endParaRPr lang="en-US" dirty="0"/>
@@ -1169,7 +1169,7 @@
         </p:nvSpPr>
         <p:spPr/>
         <p:txBody>
-          <a:bodyPr/>
+          <a:bodyPr lIns="106994" tIns="53497" rIns="106994" bIns="53497"/>
           <a:lstStyle/>
           <a:p>
             <a:fld id="{F7021451-1387-4CA6-816F-3879F97B5CBC}" type="slidenum">
@@ -1234,7 +1234,7 @@
         </p:nvSpPr>
         <p:spPr/>
         <p:txBody>
-          <a:bodyPr/>
+          <a:bodyPr lIns="106994" tIns="53497" rIns="106994" bIns="53497"/>
           <a:lstStyle/>
           <a:p>
             <a:endParaRPr lang="en-US" dirty="0"/>
@@ -1253,7 +1253,7 @@
         </p:nvSpPr>
         <p:spPr/>
         <p:txBody>
-          <a:bodyPr/>
+          <a:bodyPr lIns="106994" tIns="53497" rIns="106994" bIns="53497"/>
           <a:lstStyle/>
           <a:p>
             <a:fld id="{F7021451-1387-4CA6-816F-3879F97B5CBC}" type="slidenum">
@@ -1318,7 +1318,7 @@
         </p:nvSpPr>
         <p:spPr/>
         <p:txBody>
-          <a:bodyPr/>
+          <a:bodyPr lIns="106994" tIns="53497" rIns="106994" bIns="53497"/>
           <a:lstStyle/>
           <a:p>
             <a:endParaRPr lang="en-US" dirty="0"/>
@@ -1337,7 +1337,7 @@
         </p:nvSpPr>
         <p:spPr/>
         <p:txBody>
-          <a:bodyPr/>
+          <a:bodyPr lIns="106994" tIns="53497" rIns="106994" bIns="53497"/>
           <a:lstStyle/>
           <a:p>
             <a:fld id="{F7021451-1387-4CA6-816F-3879F97B5CBC}" type="slidenum">
@@ -1402,7 +1402,7 @@
         </p:nvSpPr>
         <p:spPr/>
         <p:txBody>
-          <a:bodyPr/>
+          <a:bodyPr lIns="106994" tIns="53497" rIns="106994" bIns="53497"/>
           <a:lstStyle/>
           <a:p>
             <a:endParaRPr lang="en-US" dirty="0"/>
@@ -1421,7 +1421,7 @@
         </p:nvSpPr>
         <p:spPr/>
         <p:txBody>
-          <a:bodyPr/>
+          <a:bodyPr lIns="106994" tIns="53497" rIns="106994" bIns="53497"/>
           <a:lstStyle/>
           <a:p>
             <a:fld id="{F7021451-1387-4CA6-816F-3879F97B5CBC}" type="slidenum">
@@ -1486,7 +1486,7 @@
         </p:nvSpPr>
         <p:spPr/>
         <p:txBody>
-          <a:bodyPr/>
+          <a:bodyPr lIns="106994" tIns="53497" rIns="106994" bIns="53497"/>
           <a:lstStyle/>
           <a:p>
             <a:endParaRPr lang="en-US" dirty="0"/>
@@ -1505,7 +1505,7 @@
         </p:nvSpPr>
         <p:spPr/>
         <p:txBody>
-          <a:bodyPr/>
+          <a:bodyPr lIns="106994" tIns="53497" rIns="106994" bIns="53497"/>
           <a:lstStyle/>
           <a:p>
             <a:fld id="{F7021451-1387-4CA6-816F-3879F97B5CBC}" type="slidenum">
@@ -1570,7 +1570,7 @@
         </p:nvSpPr>
         <p:spPr/>
         <p:txBody>
-          <a:bodyPr/>
+          <a:bodyPr lIns="106994" tIns="53497" rIns="106994" bIns="53497"/>
           <a:lstStyle/>
           <a:p>
             <a:endParaRPr lang="en-US" dirty="0"/>
@@ -1589,7 +1589,7 @@
         </p:nvSpPr>
         <p:spPr/>
         <p:txBody>
-          <a:bodyPr/>
+          <a:bodyPr lIns="106994" tIns="53497" rIns="106994" bIns="53497"/>
           <a:lstStyle/>
           <a:p>
             <a:fld id="{F7021451-1387-4CA6-816F-3879F97B5CBC}" type="slidenum">
@@ -1654,7 +1654,7 @@
         </p:nvSpPr>
         <p:spPr/>
         <p:txBody>
-          <a:bodyPr/>
+          <a:bodyPr lIns="106994" tIns="53497" rIns="106994" bIns="53497"/>
           <a:lstStyle/>
           <a:p>
             <a:endParaRPr lang="en-US" dirty="0"/>
@@ -1673,7 +1673,7 @@
         </p:nvSpPr>
         <p:spPr/>
         <p:txBody>
-          <a:bodyPr/>
+          <a:bodyPr lIns="106994" tIns="53497" rIns="106994" bIns="53497"/>
           <a:lstStyle/>
           <a:p>
             <a:fld id="{F7021451-1387-4CA6-816F-3879F97B5CBC}" type="slidenum">
@@ -1738,7 +1738,7 @@
         </p:nvSpPr>
         <p:spPr/>
         <p:txBody>
-          <a:bodyPr/>
+          <a:bodyPr lIns="106994" tIns="53497" rIns="106994" bIns="53497"/>
           <a:lstStyle/>
           <a:p>
             <a:endParaRPr lang="en-US" dirty="0"/>
@@ -1757,7 +1757,7 @@
         </p:nvSpPr>
         <p:spPr/>
         <p:txBody>
-          <a:bodyPr/>
+          <a:bodyPr lIns="106994" tIns="53497" rIns="106994" bIns="53497"/>
           <a:lstStyle/>
           <a:p>
             <a:fld id="{F7021451-1387-4CA6-816F-3879F97B5CBC}" type="slidenum">
@@ -1822,7 +1822,7 @@
         </p:nvSpPr>
         <p:spPr/>
         <p:txBody>
-          <a:bodyPr/>
+          <a:bodyPr lIns="106994" tIns="53497" rIns="106994" bIns="53497"/>
           <a:lstStyle/>
           <a:p>
             <a:endParaRPr lang="en-US" dirty="0"/>
@@ -1841,7 +1841,7 @@
         </p:nvSpPr>
         <p:spPr/>
         <p:txBody>
-          <a:bodyPr/>
+          <a:bodyPr lIns="106994" tIns="53497" rIns="106994" bIns="53497"/>
           <a:lstStyle/>
           <a:p>
             <a:fld id="{F7021451-1387-4CA6-816F-3879F97B5CBC}" type="slidenum">
@@ -1906,7 +1906,7 @@
         </p:nvSpPr>
         <p:spPr/>
         <p:txBody>
-          <a:bodyPr/>
+          <a:bodyPr lIns="106994" tIns="53497" rIns="106994" bIns="53497"/>
           <a:lstStyle/>
           <a:p>
             <a:endParaRPr lang="en-US" dirty="0"/>
@@ -1925,7 +1925,7 @@
         </p:nvSpPr>
         <p:spPr/>
         <p:txBody>
-          <a:bodyPr/>
+          <a:bodyPr lIns="106994" tIns="53497" rIns="106994" bIns="53497"/>
           <a:lstStyle/>
           <a:p>
             <a:fld id="{F7021451-1387-4CA6-816F-3879F97B5CBC}" type="slidenum">
@@ -1990,7 +1990,7 @@
         </p:nvSpPr>
         <p:spPr/>
         <p:txBody>
-          <a:bodyPr/>
+          <a:bodyPr lIns="106994" tIns="53497" rIns="106994" bIns="53497"/>
           <a:lstStyle/>
           <a:p>
             <a:endParaRPr lang="en-US" dirty="0"/>
@@ -2009,7 +2009,7 @@
         </p:nvSpPr>
         <p:spPr/>
         <p:txBody>
-          <a:bodyPr/>
+          <a:bodyPr lIns="106994" tIns="53497" rIns="106994" bIns="53497"/>
           <a:lstStyle/>
           <a:p>
             <a:fld id="{F7021451-1387-4CA6-816F-3879F97B5CBC}" type="slidenum">
@@ -2074,7 +2074,7 @@
         </p:nvSpPr>
         <p:spPr/>
         <p:txBody>
-          <a:bodyPr/>
+          <a:bodyPr lIns="106994" tIns="53497" rIns="106994" bIns="53497"/>
           <a:lstStyle/>
           <a:p>
             <a:endParaRPr lang="en-US" dirty="0"/>
@@ -2093,7 +2093,7 @@
         </p:nvSpPr>
         <p:spPr/>
         <p:txBody>
-          <a:bodyPr/>
+          <a:bodyPr lIns="106994" tIns="53497" rIns="106994" bIns="53497"/>
           <a:lstStyle/>
           <a:p>
             <a:fld id="{F7021451-1387-4CA6-816F-3879F97B5CBC}" type="slidenum">
@@ -2158,7 +2158,7 @@
         </p:nvSpPr>
         <p:spPr/>
         <p:txBody>
-          <a:bodyPr/>
+          <a:bodyPr lIns="106994" tIns="53497" rIns="106994" bIns="53497"/>
           <a:lstStyle/>
           <a:p>
             <a:endParaRPr lang="en-US" dirty="0"/>
@@ -2177,7 +2177,7 @@
         </p:nvSpPr>
         <p:spPr/>
         <p:txBody>
-          <a:bodyPr/>
+          <a:bodyPr lIns="106994" tIns="53497" rIns="106994" bIns="53497"/>
           <a:lstStyle/>
           <a:p>
             <a:fld id="{F7021451-1387-4CA6-816F-3879F97B5CBC}" type="slidenum">
@@ -2242,7 +2242,7 @@
         </p:nvSpPr>
         <p:spPr/>
         <p:txBody>
-          <a:bodyPr/>
+          <a:bodyPr lIns="106994" tIns="53497" rIns="106994" bIns="53497"/>
           <a:lstStyle/>
           <a:p>
             <a:endParaRPr lang="en-US" dirty="0"/>
@@ -2261,7 +2261,7 @@
         </p:nvSpPr>
         <p:spPr/>
         <p:txBody>
-          <a:bodyPr/>
+          <a:bodyPr lIns="106994" tIns="53497" rIns="106994" bIns="53497"/>
           <a:lstStyle/>
           <a:p>
             <a:fld id="{F7021451-1387-4CA6-816F-3879F97B5CBC}" type="slidenum">
@@ -2326,7 +2326,7 @@
         </p:nvSpPr>
         <p:spPr/>
         <p:txBody>
-          <a:bodyPr/>
+          <a:bodyPr lIns="106994" tIns="53497" rIns="106994" bIns="53497"/>
           <a:lstStyle/>
           <a:p>
             <a:endParaRPr lang="en-US" dirty="0"/>
@@ -2345,7 +2345,7 @@
         </p:nvSpPr>
         <p:spPr/>
         <p:txBody>
-          <a:bodyPr/>
+          <a:bodyPr lIns="106994" tIns="53497" rIns="106994" bIns="53497"/>
           <a:lstStyle/>
           <a:p>
             <a:fld id="{F7021451-1387-4CA6-816F-3879F97B5CBC}" type="slidenum">
@@ -2410,7 +2410,7 @@
         </p:nvSpPr>
         <p:spPr/>
         <p:txBody>
-          <a:bodyPr/>
+          <a:bodyPr lIns="106994" tIns="53497" rIns="106994" bIns="53497"/>
           <a:lstStyle/>
           <a:p>
             <a:endParaRPr lang="en-US" dirty="0"/>
@@ -2429,7 +2429,7 @@
         </p:nvSpPr>
         <p:spPr/>
         <p:txBody>
-          <a:bodyPr/>
+          <a:bodyPr lIns="106994" tIns="53497" rIns="106994" bIns="53497"/>
           <a:lstStyle/>
           <a:p>
             <a:fld id="{F7021451-1387-4CA6-816F-3879F97B5CBC}" type="slidenum">
@@ -2494,7 +2494,7 @@
         </p:nvSpPr>
         <p:spPr/>
         <p:txBody>
-          <a:bodyPr/>
+          <a:bodyPr lIns="106994" tIns="53497" rIns="106994" bIns="53497"/>
           <a:lstStyle/>
           <a:p>
             <a:endParaRPr lang="en-US" dirty="0"/>
@@ -2513,7 +2513,7 @@
         </p:nvSpPr>
         <p:spPr/>
         <p:txBody>
-          <a:bodyPr/>
+          <a:bodyPr lIns="106994" tIns="53497" rIns="106994" bIns="53497"/>
           <a:lstStyle/>
           <a:p>
             <a:fld id="{F7021451-1387-4CA6-816F-3879F97B5CBC}" type="slidenum">
@@ -2578,7 +2578,7 @@
         </p:nvSpPr>
         <p:spPr/>
         <p:txBody>
-          <a:bodyPr/>
+          <a:bodyPr lIns="106994" tIns="53497" rIns="106994" bIns="53497"/>
           <a:lstStyle/>
           <a:p>
             <a:endParaRPr lang="en-US" dirty="0"/>
@@ -2597,7 +2597,7 @@
         </p:nvSpPr>
         <p:spPr/>
         <p:txBody>
-          <a:bodyPr/>
+          <a:bodyPr lIns="106994" tIns="53497" rIns="106994" bIns="53497"/>
           <a:lstStyle/>
           <a:p>
             <a:fld id="{F7021451-1387-4CA6-816F-3879F97B5CBC}" type="slidenum">
@@ -2662,7 +2662,7 @@
         </p:nvSpPr>
         <p:spPr/>
         <p:txBody>
-          <a:bodyPr/>
+          <a:bodyPr lIns="106994" tIns="53497" rIns="106994" bIns="53497"/>
           <a:lstStyle/>
           <a:p>
             <a:endParaRPr lang="en-US" dirty="0"/>
@@ -2681,7 +2681,7 @@
         </p:nvSpPr>
         <p:spPr/>
         <p:txBody>
-          <a:bodyPr/>
+          <a:bodyPr lIns="106994" tIns="53497" rIns="106994" bIns="53497"/>
           <a:lstStyle/>
           <a:p>
             <a:fld id="{F7021451-1387-4CA6-816F-3879F97B5CBC}" type="slidenum">
@@ -2746,7 +2746,7 @@
         </p:nvSpPr>
         <p:spPr/>
         <p:txBody>
-          <a:bodyPr/>
+          <a:bodyPr lIns="106994" tIns="53497" rIns="106994" bIns="53497"/>
           <a:lstStyle/>
           <a:p>
             <a:endParaRPr lang="en-US" dirty="0"/>
@@ -2765,7 +2765,7 @@
         </p:nvSpPr>
         <p:spPr/>
         <p:txBody>
-          <a:bodyPr/>
+          <a:bodyPr lIns="106994" tIns="53497" rIns="106994" bIns="53497"/>
           <a:lstStyle/>
           <a:p>
             <a:fld id="{F7021451-1387-4CA6-816F-3879F97B5CBC}" type="slidenum">
@@ -2830,7 +2830,7 @@
         </p:nvSpPr>
         <p:spPr/>
         <p:txBody>
-          <a:bodyPr/>
+          <a:bodyPr lIns="106994" tIns="53497" rIns="106994" bIns="53497"/>
           <a:lstStyle/>
           <a:p>
             <a:endParaRPr lang="en-US" dirty="0"/>
@@ -2849,7 +2849,7 @@
         </p:nvSpPr>
         <p:spPr/>
         <p:txBody>
-          <a:bodyPr/>
+          <a:bodyPr lIns="106994" tIns="53497" rIns="106994" bIns="53497"/>
           <a:lstStyle/>
           <a:p>
             <a:fld id="{F7021451-1387-4CA6-816F-3879F97B5CBC}" type="slidenum">
@@ -2914,7 +2914,7 @@
         </p:nvSpPr>
         <p:spPr/>
         <p:txBody>
-          <a:bodyPr/>
+          <a:bodyPr lIns="106994" tIns="53497" rIns="106994" bIns="53497"/>
           <a:lstStyle/>
           <a:p>
             <a:endParaRPr lang="en-US" dirty="0"/>
@@ -2933,7 +2933,7 @@
         </p:nvSpPr>
         <p:spPr/>
         <p:txBody>
-          <a:bodyPr/>
+          <a:bodyPr lIns="106994" tIns="53497" rIns="106994" bIns="53497"/>
           <a:lstStyle/>
           <a:p>
             <a:fld id="{F7021451-1387-4CA6-816F-3879F97B5CBC}" type="slidenum">
@@ -2998,7 +2998,7 @@
         </p:nvSpPr>
         <p:spPr/>
         <p:txBody>
-          <a:bodyPr/>
+          <a:bodyPr lIns="106994" tIns="53497" rIns="106994" bIns="53497"/>
           <a:lstStyle/>
           <a:p>
             <a:endParaRPr lang="en-US" dirty="0"/>
@@ -3017,7 +3017,7 @@
         </p:nvSpPr>
         <p:spPr/>
         <p:txBody>
-          <a:bodyPr/>
+          <a:bodyPr lIns="106994" tIns="53497" rIns="106994" bIns="53497"/>
           <a:lstStyle/>
           <a:p>
             <a:fld id="{F7021451-1387-4CA6-816F-3879F97B5CBC}" type="slidenum">
@@ -8731,7 +8731,7 @@
                 <a:ea typeface="Consolas" pitchFamily="34" charset="-122"/>
                 <a:cs typeface="Consolas" pitchFamily="34" charset="-120"/>
               </a:rPr>
-              <a:t>onError(e)</a:t>
+              <a:t>onNext(item)</a:t>
             </a:r>
             <a:endParaRPr lang="en-US" sz="1100" dirty="0"/>
           </a:p>
@@ -8770,7 +8770,7 @@
                 <a:ea typeface="Calibri" pitchFamily="34" charset="-122"/>
                 <a:cs typeface="Calibri" pitchFamily="34" charset="-120"/>
               </a:rPr>
-              <a:t>Stream terminated</a:t>
+              <a:t>Publisher delivers one item.</a:t>
             </a:r>
             <a:endParaRPr lang="en-US" sz="1000" dirty="0"/>
           </a:p>
@@ -8787,7 +8787,7 @@
                 <a:ea typeface="Calibri" pitchFamily="34" charset="-122"/>
                 <a:cs typeface="Calibri" pitchFamily="34" charset="-120"/>
               </a:rPr>
-              <a:t>abnormally with an error.</a:t>
+              <a:t>Called up to n times</a:t>
             </a:r>
             <a:endParaRPr lang="en-US" sz="1000" dirty="0"/>
           </a:p>
@@ -8804,7 +8804,7 @@
                 <a:ea typeface="Calibri" pitchFamily="34" charset="-122"/>
                 <a:cs typeface="Calibri" pitchFamily="34" charset="-120"/>
               </a:rPr>
-              <a:t>Mutually exclusive with onComplete.</a:t>
+              <a:t>(as many as requested).</a:t>
             </a:r>
             <a:endParaRPr lang="en-US" sz="1000" dirty="0"/>
           </a:p>
@@ -9009,7 +9009,7 @@
                 <a:ea typeface="Consolas" pitchFamily="34" charset="-122"/>
                 <a:cs typeface="Consolas" pitchFamily="34" charset="-120"/>
               </a:rPr>
-              <a:t>onNext(item)</a:t>
+              <a:t>onComplete</a:t>
             </a:r>
             <a:endParaRPr lang="en-US" sz="1100" dirty="0"/>
           </a:p>
@@ -9048,7 +9048,7 @@
                 <a:ea typeface="Calibri" pitchFamily="34" charset="-122"/>
                 <a:cs typeface="Calibri" pitchFamily="34" charset="-120"/>
               </a:rPr>
-              <a:t>Publisher delivers one item.</a:t>
+              <a:t>Stream finished successfully.</a:t>
             </a:r>
             <a:endParaRPr lang="en-US" sz="1000" dirty="0"/>
           </a:p>
@@ -9065,24 +9065,7 @@
                 <a:ea typeface="Calibri" pitchFamily="34" charset="-122"/>
                 <a:cs typeface="Calibri" pitchFamily="34" charset="-120"/>
               </a:rPr>
-              <a:t>Called up to n times</a:t>
-            </a:r>
-            <a:endParaRPr lang="en-US" sz="1000" dirty="0"/>
-          </a:p>
-          <a:p>
-            <a:pPr marL="0" indent="0">
-              <a:buNone/>
-            </a:pPr>
-            <a:r>
-              <a:rPr lang="en-US" sz="1000" dirty="0">
-                <a:solidFill>
-                  <a:srgbClr val="1E293B"/>
-                </a:solidFill>
-                <a:latin typeface="Calibri" pitchFamily="34" charset="0"/>
-                <a:ea typeface="Calibri" pitchFamily="34" charset="-122"/>
-                <a:cs typeface="Calibri" pitchFamily="34" charset="-120"/>
-              </a:rPr>
-              <a:t>(as many as requested).</a:t>
+              <a:t>No more items will be sent.</a:t>
             </a:r>
             <a:endParaRPr lang="en-US" sz="1000" dirty="0"/>
           </a:p>
@@ -9287,7 +9270,7 @@
                 <a:ea typeface="Consolas" pitchFamily="34" charset="-122"/>
                 <a:cs typeface="Consolas" pitchFamily="34" charset="-120"/>
               </a:rPr>
-              <a:t>onComplete</a:t>
+              <a:t>onError(e)</a:t>
             </a:r>
             <a:endParaRPr lang="en-US" sz="1100" dirty="0"/>
           </a:p>
@@ -9326,7 +9309,7 @@
                 <a:ea typeface="Calibri" pitchFamily="34" charset="-122"/>
                 <a:cs typeface="Calibri" pitchFamily="34" charset="-120"/>
               </a:rPr>
-              <a:t>Stream finished successfully.</a:t>
+              <a:t>Stream terminated</a:t>
             </a:r>
             <a:endParaRPr lang="en-US" sz="1000" dirty="0"/>
           </a:p>
@@ -9343,7 +9326,7 @@
                 <a:ea typeface="Calibri" pitchFamily="34" charset="-122"/>
                 <a:cs typeface="Calibri" pitchFamily="34" charset="-120"/>
               </a:rPr>
-              <a:t>No more items will be sent.</a:t>
+              <a:t>abnormally with an error.</a:t>
             </a:r>
             <a:endParaRPr lang="en-US" sz="1000" dirty="0"/>
           </a:p>
@@ -9360,7 +9343,7 @@
                 <a:ea typeface="Calibri" pitchFamily="34" charset="-122"/>
                 <a:cs typeface="Calibri" pitchFamily="34" charset="-120"/>
               </a:rPr>
-              <a:t>Backpressure: request(n) on Subscription.</a:t>
+              <a:t>Mutually exclusive with onComplete.</a:t>
             </a:r>
             <a:endParaRPr lang="en-US" sz="1000" dirty="0"/>
           </a:p>
@@ -15292,7 +15275,7 @@
                 <a:ea typeface="Consolas" pitchFamily="34" charset="-122"/>
                 <a:cs typeface="Consolas" pitchFamily="34" charset="-120"/>
               </a:rPr>
-              <a:t>    // Simulates slow DB call</a:t>
+              <a:t>    // Simulates slow DB call — try/catch omitted</a:t>
             </a:r>
             <a:endParaRPr lang="en-US" sz="1100" dirty="0"/>
           </a:p>
@@ -15326,7 +15309,7 @@
                 <a:ea typeface="Consolas" pitchFamily="34" charset="-122"/>
                 <a:cs typeface="Consolas" pitchFamily="34" charset="-120"/>
               </a:rPr>
-              <a:t>    Product p = productRepository.findById(id);</a:t>
+              <a:t>    Product p = new Product(id, "Product " + id, ...);</a:t>
             </a:r>
             <a:endParaRPr lang="en-US" sz="1100" dirty="0"/>
           </a:p>
@@ -15798,7 +15781,7 @@
                 <a:ea typeface="Consolas" pitchFamily="34" charset="-122"/>
                 <a:cs typeface="Consolas" pitchFamily="34" charset="-120"/>
               </a:rPr>
-              <a:t>    return Mono.delay(Duration.ofMillis(500))</a:t>
+              <a:t>    return Mono.just(new Product(id, "Product " + id, ...))</a:t>
             </a:r>
             <a:endParaRPr lang="en-US" sz="1100" dirty="0"/>
           </a:p>
@@ -15815,7 +15798,7 @@
                 <a:ea typeface="Consolas" pitchFamily="34" charset="-122"/>
                 <a:cs typeface="Consolas" pitchFamily="34" charset="-120"/>
               </a:rPr>
-              <a:t>      .then(productRepository.findById(id))</a:t>
+              <a:t>      .delayElement(Duration.ofMillis(500))</a:t>
             </a:r>
             <a:endParaRPr lang="en-US" sz="1100" dirty="0"/>
           </a:p>
@@ -16308,7 +16291,7 @@
                 <a:ea typeface="Consolas" pitchFamily="34" charset="-122"/>
                 <a:cs typeface="Consolas" pitchFamily="34" charset="-120"/>
               </a:rPr>
-              <a:t>  return productRepository.findAll()</a:t>
+              <a:t>  return Flux.range(1, 20).map(i -&gt; new Product((long) i, "Product " + i, ...))</a:t>
             </a:r>
             <a:endParaRPr lang="en-US" sz="1000" dirty="0"/>
           </a:p>
@@ -16488,7 +16471,7 @@
                 <a:ea typeface="Consolas" pitchFamily="34" charset="-122"/>
                 <a:cs typeface="Consolas" pitchFamily="34" charset="-120"/>
               </a:rPr>
-              <a:t>public void streamProducts(HttpServletResponse resp) {</a:t>
+              <a:t>public void streamProducts(HttpServletResponse resp) throws IOException {</a:t>
             </a:r>
             <a:endParaRPr lang="en-US" sz="1000" dirty="0"/>
           </a:p>
@@ -16539,7 +16522,7 @@
                 <a:ea typeface="Consolas" pitchFamily="34" charset="-122"/>
                 <a:cs typeface="Consolas" pitchFamily="34" charset="-120"/>
               </a:rPr>
-              <a:t>  for (Product p : productRepository.findAll()) {</a:t>
+              <a:t>  for (int i = 1; i &lt;= 20; i++) {</a:t>
             </a:r>
             <a:endParaRPr lang="en-US" sz="1000" dirty="0"/>
           </a:p>
@@ -16556,7 +16539,7 @@
                 <a:ea typeface="Consolas" pitchFamily="34" charset="-122"/>
                 <a:cs typeface="Consolas" pitchFamily="34" charset="-120"/>
               </a:rPr>
-              <a:t>    Thread.sleep(200);</a:t>
+              <a:t>    Thread.sleep(200); // try/catch omitted</a:t>
             </a:r>
             <a:endParaRPr lang="en-US" sz="1000" dirty="0"/>
           </a:p>
@@ -16573,7 +16556,7 @@
                 <a:ea typeface="Consolas" pitchFamily="34" charset="-122"/>
                 <a:cs typeface="Consolas" pitchFamily="34" charset="-120"/>
               </a:rPr>
-              <a:t>    w.write("data: " + toJson(p) + "\n\n");</a:t>
+              <a:t>    w.write("data:" + toJson(product(i)) + "\n\n");</a:t>
             </a:r>
             <a:endParaRPr lang="en-US" sz="1000" dirty="0"/>
           </a:p>
@@ -29750,7 +29733,7 @@
         </p:nvSpPr>
         <p:spPr>
           <a:xfrm>
-            <a:off x="1645920" y="1161288"/>
+            <a:off x="2103120" y="1193292"/>
             <a:ext cx="548640" cy="320040"/>
           </a:xfrm>
           <a:prstGeom prst="rect">
@@ -29777,7 +29760,7 @@
         </p:nvSpPr>
         <p:spPr>
           <a:xfrm>
-            <a:off x="2194560" y="1161288"/>
+            <a:off x="2651760" y="1193292"/>
             <a:ext cx="3223260" cy="320040"/>
           </a:xfrm>
           <a:prstGeom prst="rect">
@@ -29811,7 +29794,7 @@
         </p:nvSpPr>
         <p:spPr>
           <a:xfrm>
-            <a:off x="5417820" y="1161288"/>
+            <a:off x="5875020" y="1193292"/>
             <a:ext cx="685800" cy="320040"/>
           </a:xfrm>
           <a:prstGeom prst="rect">
@@ -29943,7 +29926,7 @@
         </p:nvSpPr>
         <p:spPr>
           <a:xfrm>
-            <a:off x="1988820" y="1773936"/>
+            <a:off x="3063240" y="1197161"/>
             <a:ext cx="548640" cy="320040"/>
           </a:xfrm>
           <a:prstGeom prst="rect">
@@ -29970,8 +29953,8 @@
         </p:nvSpPr>
         <p:spPr>
           <a:xfrm>
-            <a:off x="2537460" y="1773936"/>
-            <a:ext cx="3909060" cy="320040"/>
+            <a:off x="2103120" y="2340864"/>
+            <a:ext cx="4457700" cy="320040"/>
           </a:xfrm>
           <a:prstGeom prst="rect">
             <a:avLst/>
@@ -30004,7 +29987,7 @@
         </p:nvSpPr>
         <p:spPr>
           <a:xfrm>
-            <a:off x="6446520" y="1773936"/>
+            <a:off x="4686300" y="1197161"/>
             <a:ext cx="685800" cy="320040"/>
           </a:xfrm>
           <a:prstGeom prst="rect">
@@ -30136,7 +30119,7 @@
         </p:nvSpPr>
         <p:spPr>
           <a:xfrm>
-            <a:off x="2331720" y="2386584"/>
+            <a:off x="3726180" y="1193292"/>
             <a:ext cx="685800" cy="320040"/>
           </a:xfrm>
           <a:prstGeom prst="rect">
@@ -30157,47 +30140,13 @@
       </p:sp>
       <p:sp>
         <p:nvSpPr>
-          <p:cNvPr id="29" name="Shape 27"/>
-          <p:cNvSpPr/>
-          <p:nvPr/>
-        </p:nvSpPr>
-        <p:spPr>
-          <a:xfrm>
-            <a:off x="3017520" y="2386584"/>
-            <a:ext cx="2743200" cy="320040"/>
-          </a:xfrm>
-          <a:prstGeom prst="rect">
-            <a:avLst/>
-          </a:prstGeom>
-          <a:solidFill>
-            <a:srgbClr val="D97706">
-              <a:alpha val="20000"/>
-            </a:srgbClr>
-          </a:solidFill>
-          <a:ln w="12700">
-            <a:solidFill>
-              <a:srgbClr val="D97706"/>
-            </a:solidFill>
-            <a:prstDash val="dash"/>
-          </a:ln>
-        </p:spPr>
-        <p:txBody>
-          <a:bodyPr/>
-          <a:lstStyle/>
-          <a:p>
-            <a:endParaRPr lang="pl-PL"/>
-          </a:p>
-        </p:txBody>
-      </p:sp>
-      <p:sp>
-        <p:nvSpPr>
           <p:cNvPr id="30" name="Shape 28"/>
           <p:cNvSpPr/>
           <p:nvPr/>
         </p:nvSpPr>
         <p:spPr>
           <a:xfrm>
-            <a:off x="5760720" y="2386584"/>
+            <a:off x="4331970" y="2340336"/>
             <a:ext cx="548640" cy="320040"/>
           </a:xfrm>
           <a:prstGeom prst="rect">
@@ -30218,47 +30167,13 @@
       </p:sp>
       <p:sp>
         <p:nvSpPr>
-          <p:cNvPr id="31" name="Shape 29"/>
-          <p:cNvSpPr/>
-          <p:nvPr/>
-        </p:nvSpPr>
-        <p:spPr>
-          <a:xfrm>
-            <a:off x="6309360" y="2386584"/>
-            <a:ext cx="1508760" cy="320040"/>
-          </a:xfrm>
-          <a:prstGeom prst="rect">
-            <a:avLst/>
-          </a:prstGeom>
-          <a:solidFill>
-            <a:srgbClr val="D97706">
-              <a:alpha val="20000"/>
-            </a:srgbClr>
-          </a:solidFill>
-          <a:ln w="12700">
-            <a:solidFill>
-              <a:srgbClr val="D97706"/>
-            </a:solidFill>
-            <a:prstDash val="dash"/>
-          </a:ln>
-        </p:spPr>
-        <p:txBody>
-          <a:bodyPr/>
-          <a:lstStyle/>
-          <a:p>
-            <a:endParaRPr lang="pl-PL"/>
-          </a:p>
-        </p:txBody>
-      </p:sp>
-      <p:sp>
-        <p:nvSpPr>
           <p:cNvPr id="32" name="Shape 30"/>
           <p:cNvSpPr/>
           <p:nvPr/>
         </p:nvSpPr>
         <p:spPr>
           <a:xfrm>
-            <a:off x="7818120" y="2386584"/>
+            <a:off x="5634990" y="2340864"/>
             <a:ext cx="480060" cy="320040"/>
           </a:xfrm>
           <a:prstGeom prst="rect">
@@ -30390,7 +30305,7 @@
         </p:nvSpPr>
         <p:spPr>
           <a:xfrm>
-            <a:off x="2674620" y="2999232"/>
+            <a:off x="2606040" y="2347722"/>
             <a:ext cx="480060" cy="320040"/>
           </a:xfrm>
           <a:prstGeom prst="rect">
@@ -30411,47 +30326,13 @@
       </p:sp>
       <p:sp>
         <p:nvSpPr>
-          <p:cNvPr id="37" name="Shape 35"/>
-          <p:cNvSpPr/>
-          <p:nvPr/>
-        </p:nvSpPr>
-        <p:spPr>
-          <a:xfrm>
-            <a:off x="3154680" y="2999232"/>
-            <a:ext cx="1920240" cy="320040"/>
-          </a:xfrm>
-          <a:prstGeom prst="rect">
-            <a:avLst/>
-          </a:prstGeom>
-          <a:solidFill>
-            <a:srgbClr val="7C3AED">
-              <a:alpha val="20000"/>
-            </a:srgbClr>
-          </a:solidFill>
-          <a:ln w="12700">
-            <a:solidFill>
-              <a:srgbClr val="7C3AED"/>
-            </a:solidFill>
-            <a:prstDash val="dash"/>
-          </a:ln>
-        </p:spPr>
-        <p:txBody>
-          <a:bodyPr/>
-          <a:lstStyle/>
-          <a:p>
-            <a:endParaRPr lang="pl-PL"/>
-          </a:p>
-        </p:txBody>
-      </p:sp>
-      <p:sp>
-        <p:nvSpPr>
           <p:cNvPr id="38" name="Shape 36"/>
           <p:cNvSpPr/>
           <p:nvPr/>
         </p:nvSpPr>
         <p:spPr>
           <a:xfrm>
-            <a:off x="5074920" y="2999232"/>
+            <a:off x="4983480" y="2334006"/>
             <a:ext cx="548640" cy="320040"/>
           </a:xfrm>
           <a:prstGeom prst="rect">
@@ -30478,7 +30359,7 @@
         </p:nvSpPr>
         <p:spPr>
           <a:xfrm>
-            <a:off x="2103120" y="1499616"/>
+            <a:off x="1965960" y="1527048"/>
             <a:ext cx="1097280" cy="182880"/>
           </a:xfrm>
           <a:prstGeom prst="rect">
@@ -30517,7 +30398,7 @@
         </p:nvSpPr>
         <p:spPr>
           <a:xfrm>
-            <a:off x="5143500" y="1499616"/>
+            <a:off x="5943600" y="1527224"/>
             <a:ext cx="1188720" cy="182880"/>
           </a:xfrm>
           <a:prstGeom prst="rect">
@@ -31034,7 +30915,7 @@
                 <a:ea typeface="Calibri" pitchFamily="34" charset="-122"/>
                 <a:cs typeface="Calibri" pitchFamily="34" charset="-120"/>
               </a:rPr>
-              <a:t>~400 MB RAM just for stacks</a:t>
+              <a:t>200–400 MB RAM just for stacks</a:t>
             </a:r>
             <a:endParaRPr lang="en-US" sz="1300" dirty="0"/>
           </a:p>
@@ -31246,7 +31127,7 @@
                 <a:ea typeface="Calibri" pitchFamily="34" charset="-122"/>
                 <a:cs typeface="Calibri" pitchFamily="34" charset="-120"/>
               </a:rPr>
-              <a:t>~16 MB RAM for threads</a:t>
+              <a:t>~4–8 MB RAM for threads</a:t>
             </a:r>
             <a:endParaRPr lang="en-US" sz="1300" dirty="0"/>
           </a:p>

</xml_diff>